<commit_message>
Correct review documents after audit
- Review 1: add hypotheses H1-H7 (from the original Review 1 draft)
  and cite Friedman; H5 no longer treats the oracle as a lower bound
- Review 2: complete Table 3 with the Ridge (log target) row and
  report values to three decimals from model_report.json; fix the
  refit description, offered-load wording and oracle wording
- Review 3: correct the SRTF preemption condition; add the remaining
  measured metrics (95th percentile, utilisation, throughput,
  fairness, starvation, RMSE, prediction time); align hypotheses
  with Review 1; separate single-seed runs from ten-seed averages;
  cite Friedman and scikit-learn; renumber references
- README, guide, transcript, slides and SRTF docstring updated to match
- docs/reviews/CHANGELOG.md lists every change and its reason

Co-Authored-By: Claude Opus 5.5 <noreply@anthropic.com>
</commit_message>
<xml_diff>
--- a/docs/reviews/Review_3.pptx
+++ b/docs/reviews/Review_3.pptx
@@ -116,13 +116,13 @@
   <p:extLst>
     <p:ext uri="{521415D9-36F7-43E2-AB2F-B90AF26B5E84}">
       <p14:sectionLst xmlns:p14="http://schemas.microsoft.com/office/powerpoint/2010/main">
-        <p14:section name="Introduction" id="{273570cf-58fc-813d-072e-c995ec7608a6}">
+        <p14:section name="Introduction" id="{50d381ac-8d45-5989-9343-098069aac3e2}">
           <p14:sldIdLst>
             <p14:sldId id="256"/>
             <p14:sldId id="257"/>
           </p14:sldIdLst>
         </p14:section>
-        <p14:section name="Performance evaluation" id="{c93ccaa5-4163-91e6-d8ff-976391ee903f}">
+        <p14:section name="Performance evaluation" id="{4fdc4ba5-3bb4-5e63-4546-a8f40481af51}">
           <p14:sldIdLst>
             <p14:sldId id="258"/>
             <p14:sldId id="259"/>
@@ -132,7 +132,7 @@
             <p14:sldId id="263"/>
           </p14:sldIdLst>
         </p14:section>
-        <p14:section name="Comparison and conclusion" id="{9b137597-795e-4a25-e798-2bff3e57b76b}">
+        <p14:section name="Comparison and conclusion" id="{a5e11f82-0d9e-eba3-265f-746ef4fb4c34}">
           <p14:sldIdLst>
             <p14:sldId id="264"/>
             <p14:sldId id="265"/>
@@ -1246,7 +1246,7 @@
           <a:p>
             <a:r>
               <a:rPr lang="en-US" dirty="0"/>
-              <a:t>Devansh: The quantum follows the workload, about 6 ms for interactive, 100 ms for CPU-bound and 3.5 ms for I/O-bound. Switching parts off shows that ageing controls the worst case, the adaptive quantum matters for long bursts, and prediction alone gives only 5%. The benefit comes from using the prediction twice.</a:t>
+              <a:t>Devansh: The quantum follows the workload, about 6 ms for interactive, close to 100 ms for CPU-bound and 3.5 ms for I/O-bound. Switching parts off shows that ageing controls the worst case, the adaptive quantum matters for long bursts, and prediction alone gives only 5%. The benefit comes from using the prediction twice.</a:t>
             </a:r>
             <a:endParaRPr lang="en-US" dirty="0"/>
           </a:p>
@@ -8455,7 +8455,7 @@
                   <a:schemeClr val="accent3"/>
                 </a:solidFill>
               </a:rPr>
-              <a:t>The quantum follows the workload: about 6 ms (interactive), 100 ms (CPU-bound), 3.5 ms (I/O-bound)</a:t>
+              <a:t>The quantum follows the workload: about 6 ms (interactive), close to 100 ms (CPU-bound), 3.5 ms (I/O-bound)</a:t>
             </a:r>
             <a:endParaRPr lang="en-US" sz="1000" dirty="0"/>
           </a:p>

</xml_diff>